<commit_message>
Update 단체 눈치 게임 assets and add ZIP slides
Co-Authored-By: Claude Opus 4.6 (1M context) <noreply@anthropic.com>
</commit_message>
<xml_diff>
--- a/public/downloads/games/group-nunchi/rules.pptx
+++ b/public/downloads/games/group-nunchi/rules.pptx
@@ -15,16 +15,12 @@
   <p:notesSz cx="6858000" cy="9144000"/>
   <p:embeddedFontLst>
     <p:embeddedFont>
-      <p:font typeface="Jua" charset="1" panose="00000000000000000000"/>
+      <p:font typeface="무궁화 고딕" charset="1" panose="02020603020101020101"/>
       <p:regular r:id="rId11"/>
     </p:embeddedFont>
     <p:embeddedFont>
-      <p:font typeface="TDTD갬성명조" charset="1" panose="02000503000000000000"/>
+      <p:font typeface="무궁화 고딕 Bold" charset="1" panose="02020603020101020101"/>
       <p:regular r:id="rId12"/>
-    </p:embeddedFont>
-    <p:embeddedFont>
-      <p:font typeface="TDTD가온" charset="1" panose="02000503000000000000"/>
-      <p:regular r:id="rId13"/>
     </p:embeddedFont>
   </p:embeddedFontLst>
   <p:defaultTextStyle>
@@ -3142,8 +3138,8 @@
         </p:nvSpPr>
         <p:spPr>
           <a:xfrm rot="0">
-            <a:off x="1028700" y="3892867"/>
-            <a:ext cx="15555091" cy="2200275"/>
+            <a:off x="1028700" y="4178617"/>
+            <a:ext cx="15555091" cy="1914525"/>
           </a:xfrm>
           <a:prstGeom prst="rect">
             <a:avLst/>
@@ -3165,10 +3161,10 @@
                 <a:solidFill>
                   <a:srgbClr val="FFFAEF"/>
                 </a:solidFill>
-                <a:latin typeface="Jua"/>
-                <a:ea typeface="Jua"/>
-                <a:cs typeface="Jua"/>
-                <a:sym typeface="Jua"/>
+                <a:latin typeface="무궁화 고딕"/>
+                <a:ea typeface="무궁화 고딕"/>
+                <a:cs typeface="무궁화 고딕"/>
+                <a:sym typeface="무궁화 고딕"/>
               </a:rPr>
               <a:t>단체 눈치게임</a:t>
             </a:r>
@@ -3183,8 +3179,8 @@
         </p:nvSpPr>
         <p:spPr>
           <a:xfrm rot="0">
-            <a:off x="15264803" y="9812655"/>
-            <a:ext cx="2637975" cy="474345"/>
+            <a:off x="14442645" y="9822180"/>
+            <a:ext cx="3460133" cy="464820"/>
           </a:xfrm>
           <a:prstGeom prst="rect">
             <a:avLst/>
@@ -3209,10 +3205,10 @@
                 <a:solidFill>
                   <a:srgbClr val="FFFFFF"/>
                 </a:solidFill>
-                <a:latin typeface="TDTD갬성명조"/>
-                <a:ea typeface="TDTD갬성명조"/>
-                <a:cs typeface="TDTD갬성명조"/>
-                <a:sym typeface="TDTD갬성명조"/>
+                <a:latin typeface="무궁화 고딕"/>
+                <a:ea typeface="무궁화 고딕"/>
+                <a:cs typeface="무궁화 고딕"/>
+                <a:sym typeface="무궁화 고딕"/>
               </a:rPr>
               <a:t>ⓒ 2026. Sunday Play</a:t>
             </a:r>
@@ -3361,8 +3357,8 @@
         </p:nvSpPr>
         <p:spPr>
           <a:xfrm rot="0">
-            <a:off x="11392761" y="600705"/>
-            <a:ext cx="5362043" cy="1600200"/>
+            <a:off x="11392761" y="819780"/>
+            <a:ext cx="5362043" cy="1381125"/>
           </a:xfrm>
           <a:prstGeom prst="rect">
             <a:avLst/>
@@ -3384,10 +3380,10 @@
                 <a:solidFill>
                   <a:srgbClr val="FFFAEF"/>
                 </a:solidFill>
-                <a:latin typeface="Jua"/>
-                <a:ea typeface="Jua"/>
-                <a:cs typeface="Jua"/>
-                <a:sym typeface="Jua"/>
+                <a:latin typeface="무궁화 고딕"/>
+                <a:ea typeface="무궁화 고딕"/>
+                <a:cs typeface="무궁화 고딕"/>
+                <a:sym typeface="무궁화 고딕"/>
               </a:rPr>
               <a:t>규칙</a:t>
             </a:r>
@@ -3403,9 +3399,9 @@
         <p:grpSpPr>
           <a:xfrm rot="0">
             <a:off x="309172" y="535073"/>
-            <a:ext cx="11933749" cy="2614620"/>
+            <a:ext cx="11933749" cy="1824045"/>
             <a:chOff x="0" y="0"/>
-            <a:chExt cx="15911666" cy="3486159"/>
+            <a:chExt cx="15911666" cy="2432059"/>
           </a:xfrm>
         </p:grpSpPr>
         <p:sp>
@@ -3417,7 +3413,7 @@
           <p:spPr>
             <a:xfrm rot="0">
               <a:off x="0" y="1444634"/>
-              <a:ext cx="15911666" cy="2041526"/>
+              <a:ext cx="15911666" cy="987426"/>
             </a:xfrm>
             <a:prstGeom prst="rect">
               <a:avLst/>
@@ -3439,20 +3435,13 @@
                   <a:solidFill>
                     <a:srgbClr val="FFFAEF"/>
                   </a:solidFill>
-                  <a:latin typeface="TDTD가온"/>
-                  <a:ea typeface="TDTD가온"/>
-                  <a:cs typeface="TDTD가온"/>
-                  <a:sym typeface="TDTD가온"/>
+                  <a:latin typeface="무궁화 고딕"/>
+                  <a:ea typeface="무궁화 고딕"/>
+                  <a:cs typeface="무궁화 고딕"/>
+                  <a:sym typeface="무궁화 고딕"/>
                 </a:rPr>
                 <a:t>팀을 구성하고 손을 잡고 원을 그려 앉습니다.</a:t>
               </a:r>
-            </a:p>
-            <a:p>
-              <a:pPr algn="l">
-                <a:lnSpc>
-                  <a:spcPts val="6299"/>
-                </a:lnSpc>
-              </a:pPr>
             </a:p>
           </p:txBody>
         </p:sp>
@@ -3464,8 +3453,8 @@
           </p:nvSpPr>
           <p:spPr>
             <a:xfrm rot="0">
-              <a:off x="0" y="-171450"/>
-              <a:ext cx="10684245" cy="1178983"/>
+              <a:off x="0" y="-47625"/>
+              <a:ext cx="10684245" cy="1055158"/>
             </a:xfrm>
             <a:prstGeom prst="rect">
               <a:avLst/>
@@ -3487,10 +3476,10 @@
                   <a:solidFill>
                     <a:srgbClr val="FFFAEF"/>
                   </a:solidFill>
-                  <a:latin typeface="Jua"/>
-                  <a:ea typeface="Jua"/>
-                  <a:cs typeface="Jua"/>
-                  <a:sym typeface="Jua"/>
+                  <a:latin typeface="무궁화 고딕 Bold"/>
+                  <a:ea typeface="무궁화 고딕 Bold"/>
+                  <a:cs typeface="무궁화 고딕 Bold"/>
+                  <a:sym typeface="무궁화 고딕 Bold"/>
                 </a:rPr>
                 <a:t>STEP 1.</a:t>
               </a:r>
@@ -3543,10 +3532,10 @@
                   <a:solidFill>
                     <a:srgbClr val="FFFAEF"/>
                   </a:solidFill>
-                  <a:latin typeface="TDTD가온"/>
-                  <a:ea typeface="TDTD가온"/>
-                  <a:cs typeface="TDTD가온"/>
-                  <a:sym typeface="TDTD가온"/>
+                  <a:latin typeface="무궁화 고딕"/>
+                  <a:ea typeface="무궁화 고딕"/>
+                  <a:cs typeface="무궁화 고딕"/>
+                  <a:sym typeface="무궁화 고딕"/>
                 </a:rPr>
                 <a:t>마지막 번호를 부르거나,</a:t>
               </a:r>
@@ -3562,10 +3551,10 @@
                   <a:solidFill>
                     <a:srgbClr val="FFFAEF"/>
                   </a:solidFill>
-                  <a:latin typeface="TDTD가온"/>
-                  <a:ea typeface="TDTD가온"/>
-                  <a:cs typeface="TDTD가온"/>
-                  <a:sym typeface="TDTD가온"/>
+                  <a:latin typeface="무궁화 고딕"/>
+                  <a:ea typeface="무궁화 고딕"/>
+                  <a:cs typeface="무궁화 고딕"/>
+                  <a:sym typeface="무궁화 고딕"/>
                 </a:rPr>
                 <a:t>같은 번호가 겹치면 탈락!</a:t>
               </a:r>
@@ -3580,8 +3569,8 @@
           </p:nvSpPr>
           <p:spPr>
             <a:xfrm rot="0">
-              <a:off x="0" y="-171450"/>
-              <a:ext cx="8060105" cy="1178984"/>
+              <a:off x="0" y="-47625"/>
+              <a:ext cx="8060105" cy="1055159"/>
             </a:xfrm>
             <a:prstGeom prst="rect">
               <a:avLst/>
@@ -3603,10 +3592,10 @@
                   <a:solidFill>
                     <a:srgbClr val="FFFAEF"/>
                   </a:solidFill>
-                  <a:latin typeface="Jua"/>
-                  <a:ea typeface="Jua"/>
-                  <a:cs typeface="Jua"/>
-                  <a:sym typeface="Jua"/>
+                  <a:latin typeface="무궁화 고딕 Bold"/>
+                  <a:ea typeface="무궁화 고딕 Bold"/>
+                  <a:cs typeface="무궁화 고딕 Bold"/>
+                  <a:sym typeface="무궁화 고딕 Bold"/>
                 </a:rPr>
                 <a:t>STEP 3.</a:t>
               </a:r>
@@ -3659,12 +3648,12 @@
                   <a:solidFill>
                     <a:srgbClr val="FFFAEF"/>
                   </a:solidFill>
-                  <a:latin typeface="TDTD가온"/>
-                  <a:ea typeface="TDTD가온"/>
-                  <a:cs typeface="TDTD가온"/>
-                  <a:sym typeface="TDTD가온"/>
+                  <a:latin typeface="무궁화 고딕"/>
+                  <a:ea typeface="무궁화 고딕"/>
+                  <a:cs typeface="무궁화 고딕"/>
+                  <a:sym typeface="무궁화 고딕"/>
                 </a:rPr>
-                <a:t> 진행자의 시작 신호에 맞춰 1부터 차례로 숫자를 외치며 일어납니다.</a:t>
+                <a:t>진행자의 시작 신호에 맞춰 1부터 차례로 숫자를 외치며 일어납니다.</a:t>
               </a:r>
             </a:p>
             <a:p>
@@ -3678,22 +3667,10 @@
                   <a:solidFill>
                     <a:srgbClr val="FFFAEF"/>
                   </a:solidFill>
-                  <a:latin typeface="TDTD가온"/>
-                  <a:ea typeface="TDTD가온"/>
-                  <a:cs typeface="TDTD가온"/>
-                  <a:sym typeface="TDTD가온"/>
-                </a:rPr>
-                <a:t> </a:t>
-              </a:r>
-              <a:r>
-                <a:rPr lang="en-US" sz="4499">
-                  <a:solidFill>
-                    <a:srgbClr val="FFFAEF"/>
-                  </a:solidFill>
-                  <a:latin typeface="TDTD가온"/>
-                  <a:ea typeface="TDTD가온"/>
-                  <a:cs typeface="TDTD가온"/>
-                  <a:sym typeface="TDTD가온"/>
+                  <a:latin typeface="무궁화 고딕"/>
+                  <a:ea typeface="무궁화 고딕"/>
+                  <a:cs typeface="무궁화 고딕"/>
+                  <a:sym typeface="무궁화 고딕"/>
                 </a:rPr>
                 <a:t>팀원 전체가 동시에 일어나야 합니다!</a:t>
               </a:r>
@@ -3708,8 +3685,8 @@
           </p:nvSpPr>
           <p:spPr>
             <a:xfrm rot="0">
-              <a:off x="0" y="-171450"/>
-              <a:ext cx="7235855" cy="1178983"/>
+              <a:off x="0" y="-47625"/>
+              <a:ext cx="7235855" cy="1055158"/>
             </a:xfrm>
             <a:prstGeom prst="rect">
               <a:avLst/>
@@ -3731,10 +3708,10 @@
                   <a:solidFill>
                     <a:srgbClr val="FFFAEF"/>
                   </a:solidFill>
-                  <a:latin typeface="Jua"/>
-                  <a:ea typeface="Jua"/>
-                  <a:cs typeface="Jua"/>
-                  <a:sym typeface="Jua"/>
+                  <a:latin typeface="무궁화 고딕 Bold"/>
+                  <a:ea typeface="무궁화 고딕 Bold"/>
+                  <a:cs typeface="무궁화 고딕 Bold"/>
+                  <a:sym typeface="무궁화 고딕 Bold"/>
                 </a:rPr>
                 <a:t>STEP 2.</a:t>
               </a:r>
@@ -3782,8 +3759,8 @@
         </p:nvSpPr>
         <p:spPr>
           <a:xfrm rot="0">
-            <a:off x="3238925" y="4092795"/>
-            <a:ext cx="11810151" cy="2200275"/>
+            <a:off x="3238925" y="4378545"/>
+            <a:ext cx="11810151" cy="1914525"/>
           </a:xfrm>
           <a:prstGeom prst="rect">
             <a:avLst/>
@@ -3805,10 +3782,10 @@
                 <a:solidFill>
                   <a:srgbClr val="000000"/>
                 </a:solidFill>
-                <a:latin typeface="Jua"/>
-                <a:ea typeface="Jua"/>
-                <a:cs typeface="Jua"/>
-                <a:sym typeface="Jua"/>
+                <a:latin typeface="무궁화 고딕"/>
+                <a:ea typeface="무궁화 고딕"/>
+                <a:cs typeface="무궁화 고딕"/>
+                <a:sym typeface="무궁화 고딕"/>
               </a:rPr>
               <a:t>팀을 나눠주세요!</a:t>
             </a:r>
@@ -3955,8 +3932,8 @@
         </p:nvSpPr>
         <p:spPr>
           <a:xfrm rot="0">
-            <a:off x="1028700" y="3892867"/>
-            <a:ext cx="15555091" cy="2200275"/>
+            <a:off x="1028700" y="4178617"/>
+            <a:ext cx="15555091" cy="1914525"/>
           </a:xfrm>
           <a:prstGeom prst="rect">
             <a:avLst/>
@@ -3978,10 +3955,10 @@
                 <a:solidFill>
                   <a:srgbClr val="FFFAEF"/>
                 </a:solidFill>
-                <a:latin typeface="Jua"/>
-                <a:ea typeface="Jua"/>
-                <a:cs typeface="Jua"/>
-                <a:sym typeface="Jua"/>
+                <a:latin typeface="무궁화 고딕"/>
+                <a:ea typeface="무궁화 고딕"/>
+                <a:cs typeface="무궁화 고딕"/>
+                <a:sym typeface="무궁화 고딕"/>
               </a:rPr>
               <a:t>단체 눈치게임</a:t>
             </a:r>
@@ -3996,8 +3973,8 @@
         </p:nvSpPr>
         <p:spPr>
           <a:xfrm rot="0">
-            <a:off x="15264803" y="9812655"/>
-            <a:ext cx="2637975" cy="474345"/>
+            <a:off x="14442645" y="9822180"/>
+            <a:ext cx="3460133" cy="464820"/>
           </a:xfrm>
           <a:prstGeom prst="rect">
             <a:avLst/>
@@ -4022,10 +3999,10 @@
                 <a:solidFill>
                   <a:srgbClr val="FFFFFF"/>
                 </a:solidFill>
-                <a:latin typeface="TDTD갬성명조"/>
-                <a:ea typeface="TDTD갬성명조"/>
-                <a:cs typeface="TDTD갬성명조"/>
-                <a:sym typeface="TDTD갬성명조"/>
+                <a:latin typeface="무궁화 고딕"/>
+                <a:ea typeface="무궁화 고딕"/>
+                <a:cs typeface="무궁화 고딕"/>
+                <a:sym typeface="무궁화 고딕"/>
               </a:rPr>
               <a:t>ⓒ 2026. Sunday Play</a:t>
             </a:r>
@@ -4097,8 +4074,8 @@
         </p:nvSpPr>
         <p:spPr>
           <a:xfrm rot="0">
-            <a:off x="4421807" y="3895725"/>
-            <a:ext cx="9444385" cy="2200275"/>
+            <a:off x="4421807" y="4181475"/>
+            <a:ext cx="9444385" cy="1914525"/>
           </a:xfrm>
           <a:prstGeom prst="rect">
             <a:avLst/>
@@ -4120,10 +4097,10 @@
                 <a:solidFill>
                   <a:srgbClr val="000000"/>
                 </a:solidFill>
-                <a:latin typeface="Jua"/>
-                <a:ea typeface="Jua"/>
-                <a:cs typeface="Jua"/>
-                <a:sym typeface="Jua"/>
+                <a:latin typeface="무궁화 고딕"/>
+                <a:ea typeface="무궁화 고딕"/>
+                <a:cs typeface="무궁화 고딕"/>
+                <a:sym typeface="무궁화 고딕"/>
               </a:rPr>
               <a:t>감사합니다!</a:t>
             </a:r>

</xml_diff>